<commit_message>
Add photos to PPT slides (78 photos across all properties)
https://claude.ai/code/session_01X22yUdMQ8ieWou29hb84DM
</commit_message>
<xml_diff>
--- a/物件一覧.pptx
+++ b/物件一覧.pptx
@@ -5409,9 +5409,33 @@
           </a:p>
         </p:txBody>
       </p:sp>
-      <p:sp>
-        <p:nvSpPr>
-          <p:cNvPr id="59" name="Rectangle 58"/>
+      <p:pic>
+        <p:nvPicPr>
+          <p:cNvPr id="59" name="Picture 58" descr="1779266493906_uklnd.jpg"/>
+          <p:cNvPicPr>
+            <a:picLocks noChangeAspect="1"/>
+          </p:cNvPicPr>
+          <p:nvPr/>
+        </p:nvPicPr>
+        <p:blipFill>
+          <a:blip r:embed="rId2"/>
+          <a:stretch>
+            <a:fillRect/>
+          </a:stretch>
+        </p:blipFill>
+        <p:spPr>
+          <a:xfrm>
+            <a:off x="6929999" y="2043600"/>
+            <a:ext cx="2550601" cy="3400801"/>
+          </a:xfrm>
+          <a:prstGeom prst="rect">
+            <a:avLst/>
+          </a:prstGeom>
+        </p:spPr>
+      </p:pic>
+      <p:sp>
+        <p:nvSpPr>
+          <p:cNvPr id="60" name="Rectangle 59"/>
           <p:cNvSpPr/>
           <p:nvPr/>
         </p:nvSpPr>
@@ -5452,6 +5476,30 @@
           </a:p>
         </p:txBody>
       </p:sp>
+      <p:pic>
+        <p:nvPicPr>
+          <p:cNvPr id="61" name="Picture 60" descr="1779266493908_zwzbj.jpg"/>
+          <p:cNvPicPr>
+            <a:picLocks noChangeAspect="1"/>
+          </p:cNvPicPr>
+          <p:nvPr/>
+        </p:nvPicPr>
+        <p:blipFill>
+          <a:blip r:embed="rId3"/>
+          <a:stretch>
+            <a:fillRect/>
+          </a:stretch>
+        </p:blipFill>
+        <p:spPr>
+          <a:xfrm>
+            <a:off x="9516600" y="3259386"/>
+            <a:ext cx="2550601" cy="969228"/>
+          </a:xfrm>
+          <a:prstGeom prst="rect">
+            <a:avLst/>
+          </a:prstGeom>
+        </p:spPr>
+      </p:pic>
     </p:spTree>
   </p:cSld>
   <p:clrMapOvr>
@@ -7606,9 +7654,33 @@
           </a:p>
         </p:txBody>
       </p:sp>
-      <p:sp>
-        <p:nvSpPr>
-          <p:cNvPr id="59" name="Rectangle 58"/>
+      <p:pic>
+        <p:nvPicPr>
+          <p:cNvPr id="59" name="Picture 58" descr="1779266493910_33qi5.jpg"/>
+          <p:cNvPicPr>
+            <a:picLocks noChangeAspect="1"/>
+          </p:cNvPicPr>
+          <p:nvPr/>
+        </p:nvPicPr>
+        <p:blipFill>
+          <a:blip r:embed="rId2"/>
+          <a:stretch>
+            <a:fillRect/>
+          </a:stretch>
+        </p:blipFill>
+        <p:spPr>
+          <a:xfrm>
+            <a:off x="6929999" y="2468700"/>
+            <a:ext cx="2550601" cy="2550601"/>
+          </a:xfrm>
+          <a:prstGeom prst="rect">
+            <a:avLst/>
+          </a:prstGeom>
+        </p:spPr>
+      </p:pic>
+      <p:sp>
+        <p:nvSpPr>
+          <p:cNvPr id="60" name="Rectangle 59"/>
           <p:cNvSpPr/>
           <p:nvPr/>
         </p:nvSpPr>
@@ -7649,6 +7721,30 @@
           </a:p>
         </p:txBody>
       </p:sp>
+      <p:pic>
+        <p:nvPicPr>
+          <p:cNvPr id="61" name="Picture 60" descr="1779266493911_yhc4b.jpg"/>
+          <p:cNvPicPr>
+            <a:picLocks noChangeAspect="1"/>
+          </p:cNvPicPr>
+          <p:nvPr/>
+        </p:nvPicPr>
+        <p:blipFill>
+          <a:blip r:embed="rId3"/>
+          <a:stretch>
+            <a:fillRect/>
+          </a:stretch>
+        </p:blipFill>
+        <p:spPr>
+          <a:xfrm>
+            <a:off x="9576863" y="756000"/>
+            <a:ext cx="2430075" cy="5976001"/>
+          </a:xfrm>
+          <a:prstGeom prst="rect">
+            <a:avLst/>
+          </a:prstGeom>
+        </p:spPr>
+      </p:pic>
     </p:spTree>
   </p:cSld>
   <p:clrMapOvr>
@@ -9803,9 +9899,33 @@
           </a:p>
         </p:txBody>
       </p:sp>
-      <p:sp>
-        <p:nvSpPr>
-          <p:cNvPr id="59" name="Rectangle 58"/>
+      <p:pic>
+        <p:nvPicPr>
+          <p:cNvPr id="59" name="Picture 58" descr="1779266493913_rax0d.jpg"/>
+          <p:cNvPicPr>
+            <a:picLocks noChangeAspect="1"/>
+          </p:cNvPicPr>
+          <p:nvPr/>
+        </p:nvPicPr>
+        <p:blipFill>
+          <a:blip r:embed="rId2"/>
+          <a:stretch>
+            <a:fillRect/>
+          </a:stretch>
+        </p:blipFill>
+        <p:spPr>
+          <a:xfrm>
+            <a:off x="7221299" y="756000"/>
+            <a:ext cx="1968000" cy="1968000"/>
+          </a:xfrm>
+          <a:prstGeom prst="rect">
+            <a:avLst/>
+          </a:prstGeom>
+        </p:spPr>
+      </p:pic>
+      <p:sp>
+        <p:nvSpPr>
+          <p:cNvPr id="60" name="Rectangle 59"/>
           <p:cNvSpPr/>
           <p:nvPr/>
         </p:nvSpPr>
@@ -9846,9 +9966,33 @@
           </a:p>
         </p:txBody>
       </p:sp>
-      <p:sp>
-        <p:nvSpPr>
-          <p:cNvPr id="60" name="Rectangle 59"/>
+      <p:pic>
+        <p:nvPicPr>
+          <p:cNvPr id="61" name="Picture 60" descr="1779266493914_itmy2.jpg"/>
+          <p:cNvPicPr>
+            <a:picLocks noChangeAspect="1"/>
+          </p:cNvPicPr>
+          <p:nvPr/>
+        </p:nvPicPr>
+        <p:blipFill>
+          <a:blip r:embed="rId3"/>
+          <a:stretch>
+            <a:fillRect/>
+          </a:stretch>
+        </p:blipFill>
+        <p:spPr>
+          <a:xfrm>
+            <a:off x="10299900" y="756000"/>
+            <a:ext cx="984000" cy="1968000"/>
+          </a:xfrm>
+          <a:prstGeom prst="rect">
+            <a:avLst/>
+          </a:prstGeom>
+        </p:spPr>
+      </p:pic>
+      <p:sp>
+        <p:nvSpPr>
+          <p:cNvPr id="62" name="Rectangle 61"/>
           <p:cNvSpPr/>
           <p:nvPr/>
         </p:nvSpPr>
@@ -9889,9 +10033,33 @@
           </a:p>
         </p:txBody>
       </p:sp>
-      <p:sp>
-        <p:nvSpPr>
-          <p:cNvPr id="61" name="Rectangle 60"/>
+      <p:pic>
+        <p:nvPicPr>
+          <p:cNvPr id="63" name="Picture 62" descr="1779266493915_g11l4.jpg"/>
+          <p:cNvPicPr>
+            <a:picLocks noChangeAspect="1"/>
+          </p:cNvPicPr>
+          <p:nvPr/>
+        </p:nvPicPr>
+        <p:blipFill>
+          <a:blip r:embed="rId4"/>
+          <a:stretch>
+            <a:fillRect/>
+          </a:stretch>
+        </p:blipFill>
+        <p:spPr>
+          <a:xfrm>
+            <a:off x="7356144" y="2760000"/>
+            <a:ext cx="1698311" cy="1968000"/>
+          </a:xfrm>
+          <a:prstGeom prst="rect">
+            <a:avLst/>
+          </a:prstGeom>
+        </p:spPr>
+      </p:pic>
+      <p:sp>
+        <p:nvSpPr>
+          <p:cNvPr id="64" name="Rectangle 63"/>
           <p:cNvSpPr/>
           <p:nvPr/>
         </p:nvSpPr>
@@ -9932,9 +10100,33 @@
           </a:p>
         </p:txBody>
       </p:sp>
-      <p:sp>
-        <p:nvSpPr>
-          <p:cNvPr id="62" name="Rectangle 61"/>
+      <p:pic>
+        <p:nvPicPr>
+          <p:cNvPr id="65" name="Picture 64" descr="1779266493916_a1snz.jpg"/>
+          <p:cNvPicPr>
+            <a:picLocks noChangeAspect="1"/>
+          </p:cNvPicPr>
+          <p:nvPr/>
+        </p:nvPicPr>
+        <p:blipFill>
+          <a:blip r:embed="rId5"/>
+          <a:stretch>
+            <a:fillRect/>
+          </a:stretch>
+        </p:blipFill>
+        <p:spPr>
+          <a:xfrm>
+            <a:off x="9937050" y="2760000"/>
+            <a:ext cx="1709700" cy="1968000"/>
+          </a:xfrm>
+          <a:prstGeom prst="rect">
+            <a:avLst/>
+          </a:prstGeom>
+        </p:spPr>
+      </p:pic>
+      <p:sp>
+        <p:nvSpPr>
+          <p:cNvPr id="66" name="Rectangle 65"/>
           <p:cNvSpPr/>
           <p:nvPr/>
         </p:nvSpPr>
@@ -9975,9 +10167,33 @@
           </a:p>
         </p:txBody>
       </p:sp>
-      <p:sp>
-        <p:nvSpPr>
-          <p:cNvPr id="63" name="Rectangle 62"/>
+      <p:pic>
+        <p:nvPicPr>
+          <p:cNvPr id="67" name="Picture 66" descr="1779266493918_oydm3.jpg"/>
+          <p:cNvPicPr>
+            <a:picLocks noChangeAspect="1"/>
+          </p:cNvPicPr>
+          <p:nvPr/>
+        </p:nvPicPr>
+        <p:blipFill>
+          <a:blip r:embed="rId6"/>
+          <a:stretch>
+            <a:fillRect/>
+          </a:stretch>
+        </p:blipFill>
+        <p:spPr>
+          <a:xfrm>
+            <a:off x="7713299" y="4764000"/>
+            <a:ext cx="984000" cy="1968000"/>
+          </a:xfrm>
+          <a:prstGeom prst="rect">
+            <a:avLst/>
+          </a:prstGeom>
+        </p:spPr>
+      </p:pic>
+      <p:sp>
+        <p:nvSpPr>
+          <p:cNvPr id="68" name="Rectangle 67"/>
           <p:cNvSpPr/>
           <p:nvPr/>
         </p:nvSpPr>
@@ -10018,9 +10234,33 @@
           </a:p>
         </p:txBody>
       </p:sp>
-      <p:sp>
-        <p:nvSpPr>
-          <p:cNvPr id="64" name="Rectangle 63"/>
+      <p:pic>
+        <p:nvPicPr>
+          <p:cNvPr id="69" name="Picture 68" descr="1779266493920_va8h2.jpg"/>
+          <p:cNvPicPr>
+            <a:picLocks noChangeAspect="1"/>
+          </p:cNvPicPr>
+          <p:nvPr/>
+        </p:nvPicPr>
+        <p:blipFill>
+          <a:blip r:embed="rId7"/>
+          <a:stretch>
+            <a:fillRect/>
+          </a:stretch>
+        </p:blipFill>
+        <p:spPr>
+          <a:xfrm>
+            <a:off x="9917370" y="4764000"/>
+            <a:ext cx="1749060" cy="1968000"/>
+          </a:xfrm>
+          <a:prstGeom prst="rect">
+            <a:avLst/>
+          </a:prstGeom>
+        </p:spPr>
+      </p:pic>
+      <p:sp>
+        <p:nvSpPr>
+          <p:cNvPr id="70" name="Rectangle 69"/>
           <p:cNvSpPr/>
           <p:nvPr/>
         </p:nvSpPr>
@@ -10065,7 +10305,7 @@
       </p:sp>
       <p:sp>
         <p:nvSpPr>
-          <p:cNvPr id="65" name="TextBox 64"/>
+          <p:cNvPr id="71" name="TextBox 70"/>
           <p:cNvSpPr txBox="1"/>
           <p:nvPr/>
         </p:nvSpPr>
@@ -12251,9 +12491,33 @@
           </a:p>
         </p:txBody>
       </p:sp>
-      <p:sp>
-        <p:nvSpPr>
-          <p:cNvPr id="59" name="Rectangle 58"/>
+      <p:pic>
+        <p:nvPicPr>
+          <p:cNvPr id="59" name="Picture 58" descr="1779266493924_pg1l0.jpg"/>
+          <p:cNvPicPr>
+            <a:picLocks noChangeAspect="1"/>
+          </p:cNvPicPr>
+          <p:nvPr/>
+        </p:nvPicPr>
+        <p:blipFill>
+          <a:blip r:embed="rId2"/>
+          <a:stretch>
+            <a:fillRect/>
+          </a:stretch>
+        </p:blipFill>
+        <p:spPr>
+          <a:xfrm>
+            <a:off x="6929999" y="965699"/>
+            <a:ext cx="2550601" cy="2550601"/>
+          </a:xfrm>
+          <a:prstGeom prst="rect">
+            <a:avLst/>
+          </a:prstGeom>
+        </p:spPr>
+      </p:pic>
+      <p:sp>
+        <p:nvSpPr>
+          <p:cNvPr id="60" name="Rectangle 59"/>
           <p:cNvSpPr/>
           <p:nvPr/>
         </p:nvSpPr>
@@ -12294,9 +12558,33 @@
           </a:p>
         </p:txBody>
       </p:sp>
-      <p:sp>
-        <p:nvSpPr>
-          <p:cNvPr id="60" name="Rectangle 59"/>
+      <p:pic>
+        <p:nvPicPr>
+          <p:cNvPr id="61" name="Picture 60" descr="1779266493926_o9heg.jpg"/>
+          <p:cNvPicPr>
+            <a:picLocks noChangeAspect="1"/>
+          </p:cNvPicPr>
+          <p:nvPr/>
+        </p:nvPicPr>
+        <p:blipFill>
+          <a:blip r:embed="rId3"/>
+          <a:stretch>
+            <a:fillRect/>
+          </a:stretch>
+        </p:blipFill>
+        <p:spPr>
+          <a:xfrm>
+            <a:off x="9516600" y="965699"/>
+            <a:ext cx="2550601" cy="2550601"/>
+          </a:xfrm>
+          <a:prstGeom prst="rect">
+            <a:avLst/>
+          </a:prstGeom>
+        </p:spPr>
+      </p:pic>
+      <p:sp>
+        <p:nvSpPr>
+          <p:cNvPr id="62" name="Rectangle 61"/>
           <p:cNvSpPr/>
           <p:nvPr/>
         </p:nvSpPr>
@@ -12337,9 +12625,33 @@
           </a:p>
         </p:txBody>
       </p:sp>
-      <p:sp>
-        <p:nvSpPr>
-          <p:cNvPr id="61" name="Rectangle 60"/>
+      <p:pic>
+        <p:nvPicPr>
+          <p:cNvPr id="63" name="Picture 62" descr="1779266493927_ue5qp.jpg"/>
+          <p:cNvPicPr>
+            <a:picLocks noChangeAspect="1"/>
+          </p:cNvPicPr>
+          <p:nvPr/>
+        </p:nvPicPr>
+        <p:blipFill>
+          <a:blip r:embed="rId4"/>
+          <a:stretch>
+            <a:fillRect/>
+          </a:stretch>
+        </p:blipFill>
+        <p:spPr>
+          <a:xfrm>
+            <a:off x="6929999" y="3971699"/>
+            <a:ext cx="2550601" cy="2550601"/>
+          </a:xfrm>
+          <a:prstGeom prst="rect">
+            <a:avLst/>
+          </a:prstGeom>
+        </p:spPr>
+      </p:pic>
+      <p:sp>
+        <p:nvSpPr>
+          <p:cNvPr id="64" name="Rectangle 63"/>
           <p:cNvSpPr/>
           <p:nvPr/>
         </p:nvSpPr>
@@ -12380,6 +12692,30 @@
           </a:p>
         </p:txBody>
       </p:sp>
+      <p:pic>
+        <p:nvPicPr>
+          <p:cNvPr id="65" name="Picture 64" descr="1779266493928_jr5aw.jpg"/>
+          <p:cNvPicPr>
+            <a:picLocks noChangeAspect="1"/>
+          </p:cNvPicPr>
+          <p:nvPr/>
+        </p:nvPicPr>
+        <p:blipFill>
+          <a:blip r:embed="rId5"/>
+          <a:stretch>
+            <a:fillRect/>
+          </a:stretch>
+        </p:blipFill>
+        <p:spPr>
+          <a:xfrm>
+            <a:off x="9516600" y="3971699"/>
+            <a:ext cx="2550601" cy="2550601"/>
+          </a:xfrm>
+          <a:prstGeom prst="rect">
+            <a:avLst/>
+          </a:prstGeom>
+        </p:spPr>
+      </p:pic>
     </p:spTree>
   </p:cSld>
   <p:clrMapOvr>
@@ -14534,9 +14870,33 @@
           </a:p>
         </p:txBody>
       </p:sp>
-      <p:sp>
-        <p:nvSpPr>
-          <p:cNvPr id="59" name="Rectangle 58"/>
+      <p:pic>
+        <p:nvPicPr>
+          <p:cNvPr id="59" name="Picture 58" descr="1779266493930_yt6kq.jpg"/>
+          <p:cNvPicPr>
+            <a:picLocks noChangeAspect="1"/>
+          </p:cNvPicPr>
+          <p:nvPr/>
+        </p:nvPicPr>
+        <p:blipFill>
+          <a:blip r:embed="rId2"/>
+          <a:stretch>
+            <a:fillRect/>
+          </a:stretch>
+        </p:blipFill>
+        <p:spPr>
+          <a:xfrm>
+            <a:off x="6929999" y="2468700"/>
+            <a:ext cx="2550601" cy="2550601"/>
+          </a:xfrm>
+          <a:prstGeom prst="rect">
+            <a:avLst/>
+          </a:prstGeom>
+        </p:spPr>
+      </p:pic>
+      <p:sp>
+        <p:nvSpPr>
+          <p:cNvPr id="60" name="Rectangle 59"/>
           <p:cNvSpPr/>
           <p:nvPr/>
         </p:nvSpPr>
@@ -14577,6 +14937,30 @@
           </a:p>
         </p:txBody>
       </p:sp>
+      <p:pic>
+        <p:nvPicPr>
+          <p:cNvPr id="61" name="Picture 60" descr="1779266493931_dinsd.jpg"/>
+          <p:cNvPicPr>
+            <a:picLocks noChangeAspect="1"/>
+          </p:cNvPicPr>
+          <p:nvPr/>
+        </p:nvPicPr>
+        <p:blipFill>
+          <a:blip r:embed="rId3"/>
+          <a:stretch>
+            <a:fillRect/>
+          </a:stretch>
+        </p:blipFill>
+        <p:spPr>
+          <a:xfrm>
+            <a:off x="9516600" y="2468700"/>
+            <a:ext cx="2550601" cy="2550601"/>
+          </a:xfrm>
+          <a:prstGeom prst="rect">
+            <a:avLst/>
+          </a:prstGeom>
+        </p:spPr>
+      </p:pic>
     </p:spTree>
   </p:cSld>
   <p:clrMapOvr>
@@ -16731,9 +17115,33 @@
           </a:p>
         </p:txBody>
       </p:sp>
-      <p:sp>
-        <p:nvSpPr>
-          <p:cNvPr id="59" name="Rectangle 58"/>
+      <p:pic>
+        <p:nvPicPr>
+          <p:cNvPr id="59" name="Picture 58" descr="1779266493933_wxm5q.jpg"/>
+          <p:cNvPicPr>
+            <a:picLocks noChangeAspect="1"/>
+          </p:cNvPicPr>
+          <p:nvPr/>
+        </p:nvPicPr>
+        <p:blipFill>
+          <a:blip r:embed="rId2"/>
+          <a:stretch>
+            <a:fillRect/>
+          </a:stretch>
+        </p:blipFill>
+        <p:spPr>
+          <a:xfrm>
+            <a:off x="6929999" y="2787525"/>
+            <a:ext cx="2550601" cy="1912950"/>
+          </a:xfrm>
+          <a:prstGeom prst="rect">
+            <a:avLst/>
+          </a:prstGeom>
+        </p:spPr>
+      </p:pic>
+      <p:sp>
+        <p:nvSpPr>
+          <p:cNvPr id="60" name="Rectangle 59"/>
           <p:cNvSpPr/>
           <p:nvPr/>
         </p:nvSpPr>
@@ -16774,6 +17182,30 @@
           </a:p>
         </p:txBody>
       </p:sp>
+      <p:pic>
+        <p:nvPicPr>
+          <p:cNvPr id="61" name="Picture 60" descr="1779266493934_f1ymd.jpg"/>
+          <p:cNvPicPr>
+            <a:picLocks noChangeAspect="1"/>
+          </p:cNvPicPr>
+          <p:nvPr/>
+        </p:nvPicPr>
+        <p:blipFill>
+          <a:blip r:embed="rId3"/>
+          <a:stretch>
+            <a:fillRect/>
+          </a:stretch>
+        </p:blipFill>
+        <p:spPr>
+          <a:xfrm>
+            <a:off x="9516600" y="2468700"/>
+            <a:ext cx="2550601" cy="2550601"/>
+          </a:xfrm>
+          <a:prstGeom prst="rect">
+            <a:avLst/>
+          </a:prstGeom>
+        </p:spPr>
+      </p:pic>
     </p:spTree>
   </p:cSld>
   <p:clrMapOvr>
@@ -19005,9 +19437,33 @@
           </a:p>
         </p:txBody>
       </p:sp>
-      <p:sp>
-        <p:nvSpPr>
-          <p:cNvPr id="61" name="Rectangle 60"/>
+      <p:pic>
+        <p:nvPicPr>
+          <p:cNvPr id="61" name="Picture 60" descr="1779266493936_8ygdh.jpg"/>
+          <p:cNvPicPr>
+            <a:picLocks noChangeAspect="1"/>
+          </p:cNvPicPr>
+          <p:nvPr/>
+        </p:nvPicPr>
+        <p:blipFill>
+          <a:blip r:embed="rId2"/>
+          <a:stretch>
+            <a:fillRect/>
+          </a:stretch>
+        </p:blipFill>
+        <p:spPr>
+          <a:xfrm>
+            <a:off x="6929999" y="2787525"/>
+            <a:ext cx="2550601" cy="1912950"/>
+          </a:xfrm>
+          <a:prstGeom prst="rect">
+            <a:avLst/>
+          </a:prstGeom>
+        </p:spPr>
+      </p:pic>
+      <p:sp>
+        <p:nvSpPr>
+          <p:cNvPr id="62" name="Rectangle 61"/>
           <p:cNvSpPr/>
           <p:nvPr/>
         </p:nvSpPr>
@@ -19048,6 +19504,30 @@
           </a:p>
         </p:txBody>
       </p:sp>
+      <p:pic>
+        <p:nvPicPr>
+          <p:cNvPr id="63" name="Picture 62" descr="1779266493938_bfux8.jpg"/>
+          <p:cNvPicPr>
+            <a:picLocks noChangeAspect="1"/>
+          </p:cNvPicPr>
+          <p:nvPr/>
+        </p:nvPicPr>
+        <p:blipFill>
+          <a:blip r:embed="rId3"/>
+          <a:stretch>
+            <a:fillRect/>
+          </a:stretch>
+        </p:blipFill>
+        <p:spPr>
+          <a:xfrm>
+            <a:off x="9516600" y="2468700"/>
+            <a:ext cx="2550601" cy="2550601"/>
+          </a:xfrm>
+          <a:prstGeom prst="rect">
+            <a:avLst/>
+          </a:prstGeom>
+        </p:spPr>
+      </p:pic>
     </p:spTree>
   </p:cSld>
   <p:clrMapOvr>
@@ -21254,9 +21734,33 @@
           </a:p>
         </p:txBody>
       </p:sp>
-      <p:sp>
-        <p:nvSpPr>
-          <p:cNvPr id="57" name="Rectangle 56"/>
+      <p:pic>
+        <p:nvPicPr>
+          <p:cNvPr id="57" name="Picture 56" descr="1779265156830_a0xmv.jpg"/>
+          <p:cNvPicPr>
+            <a:picLocks noChangeAspect="1"/>
+          </p:cNvPicPr>
+          <p:nvPr/>
+        </p:nvPicPr>
+        <p:blipFill>
+          <a:blip r:embed="rId2"/>
+          <a:stretch>
+            <a:fillRect/>
+          </a:stretch>
+        </p:blipFill>
+        <p:spPr>
+          <a:xfrm>
+            <a:off x="7368749" y="756000"/>
+            <a:ext cx="1673100" cy="2970000"/>
+          </a:xfrm>
+          <a:prstGeom prst="rect">
+            <a:avLst/>
+          </a:prstGeom>
+        </p:spPr>
+      </p:pic>
+      <p:sp>
+        <p:nvSpPr>
+          <p:cNvPr id="58" name="Rectangle 57"/>
           <p:cNvSpPr/>
           <p:nvPr/>
         </p:nvSpPr>
@@ -21297,9 +21801,33 @@
           </a:p>
         </p:txBody>
       </p:sp>
-      <p:sp>
-        <p:nvSpPr>
-          <p:cNvPr id="58" name="Rectangle 57"/>
+      <p:pic>
+        <p:nvPicPr>
+          <p:cNvPr id="59" name="Picture 58" descr="1779266421349_v405i.jpg"/>
+          <p:cNvPicPr>
+            <a:picLocks noChangeAspect="1"/>
+          </p:cNvPicPr>
+          <p:nvPr/>
+        </p:nvPicPr>
+        <p:blipFill>
+          <a:blip r:embed="rId3"/>
+          <a:stretch>
+            <a:fillRect/>
+          </a:stretch>
+        </p:blipFill>
+        <p:spPr>
+          <a:xfrm>
+            <a:off x="10009773" y="756000"/>
+            <a:ext cx="1564255" cy="2970000"/>
+          </a:xfrm>
+          <a:prstGeom prst="rect">
+            <a:avLst/>
+          </a:prstGeom>
+        </p:spPr>
+      </p:pic>
+      <p:sp>
+        <p:nvSpPr>
+          <p:cNvPr id="60" name="Rectangle 59"/>
           <p:cNvSpPr/>
           <p:nvPr/>
         </p:nvSpPr>
@@ -21340,6 +21868,30 @@
           </a:p>
         </p:txBody>
       </p:sp>
+      <p:pic>
+        <p:nvPicPr>
+          <p:cNvPr id="61" name="Picture 60" descr="1779266476803_np7vt.jpg"/>
+          <p:cNvPicPr>
+            <a:picLocks noChangeAspect="1"/>
+          </p:cNvPicPr>
+          <p:nvPr/>
+        </p:nvPicPr>
+        <p:blipFill>
+          <a:blip r:embed="rId4"/>
+          <a:stretch>
+            <a:fillRect/>
+          </a:stretch>
+        </p:blipFill>
+        <p:spPr>
+          <a:xfrm>
+            <a:off x="7091549" y="3762000"/>
+            <a:ext cx="2227500" cy="2970000"/>
+          </a:xfrm>
+          <a:prstGeom prst="rect">
+            <a:avLst/>
+          </a:prstGeom>
+        </p:spPr>
+      </p:pic>
     </p:spTree>
   </p:cSld>
   <p:clrMapOvr>
@@ -23494,9 +24046,33 @@
           </a:p>
         </p:txBody>
       </p:sp>
-      <p:sp>
-        <p:nvSpPr>
-          <p:cNvPr id="59" name="Rectangle 58"/>
+      <p:pic>
+        <p:nvPicPr>
+          <p:cNvPr id="59" name="Picture 58" descr="1779265924924_1niqd.jpg"/>
+          <p:cNvPicPr>
+            <a:picLocks noChangeAspect="1"/>
+          </p:cNvPicPr>
+          <p:nvPr/>
+        </p:nvPicPr>
+        <p:blipFill>
+          <a:blip r:embed="rId2"/>
+          <a:stretch>
+            <a:fillRect/>
+          </a:stretch>
+        </p:blipFill>
+        <p:spPr>
+          <a:xfrm>
+            <a:off x="6929999" y="1300525"/>
+            <a:ext cx="2550601" cy="4886951"/>
+          </a:xfrm>
+          <a:prstGeom prst="rect">
+            <a:avLst/>
+          </a:prstGeom>
+        </p:spPr>
+      </p:pic>
+      <p:sp>
+        <p:nvSpPr>
+          <p:cNvPr id="60" name="Rectangle 59"/>
           <p:cNvSpPr/>
           <p:nvPr/>
         </p:nvSpPr>
@@ -23537,6 +24113,30 @@
           </a:p>
         </p:txBody>
       </p:sp>
+      <p:pic>
+        <p:nvPicPr>
+          <p:cNvPr id="61" name="Picture 60" descr="1779265934882_ei4zq.jpg"/>
+          <p:cNvPicPr>
+            <a:picLocks noChangeAspect="1"/>
+          </p:cNvPicPr>
+          <p:nvPr/>
+        </p:nvPicPr>
+        <p:blipFill>
+          <a:blip r:embed="rId3"/>
+          <a:stretch>
+            <a:fillRect/>
+          </a:stretch>
+        </p:blipFill>
+        <p:spPr>
+          <a:xfrm>
+            <a:off x="9516600" y="2787525"/>
+            <a:ext cx="2550601" cy="1912950"/>
+          </a:xfrm>
+          <a:prstGeom prst="rect">
+            <a:avLst/>
+          </a:prstGeom>
+        </p:spPr>
+      </p:pic>
     </p:spTree>
   </p:cSld>
   <p:clrMapOvr>
@@ -25820,9 +26420,33 @@
           </a:p>
         </p:txBody>
       </p:sp>
-      <p:sp>
-        <p:nvSpPr>
-          <p:cNvPr id="59" name="Rectangle 58"/>
+      <p:pic>
+        <p:nvPicPr>
+          <p:cNvPr id="59" name="Picture 58" descr="1779267449728_ygvh2.jpg"/>
+          <p:cNvPicPr>
+            <a:picLocks noChangeAspect="1"/>
+          </p:cNvPicPr>
+          <p:nvPr/>
+        </p:nvPicPr>
+        <p:blipFill>
+          <a:blip r:embed="rId2"/>
+          <a:stretch>
+            <a:fillRect/>
+          </a:stretch>
+        </p:blipFill>
+        <p:spPr>
+          <a:xfrm>
+            <a:off x="6929999" y="2043600"/>
+            <a:ext cx="2550601" cy="3400801"/>
+          </a:xfrm>
+          <a:prstGeom prst="rect">
+            <a:avLst/>
+          </a:prstGeom>
+        </p:spPr>
+      </p:pic>
+      <p:sp>
+        <p:nvSpPr>
+          <p:cNvPr id="60" name="Rectangle 59"/>
           <p:cNvSpPr/>
           <p:nvPr/>
         </p:nvSpPr>
@@ -25863,6 +26487,30 @@
           </a:p>
         </p:txBody>
       </p:sp>
+      <p:pic>
+        <p:nvPicPr>
+          <p:cNvPr id="61" name="Picture 60" descr="1779267467536_cwtm4.jpg"/>
+          <p:cNvPicPr>
+            <a:picLocks noChangeAspect="1"/>
+          </p:cNvPicPr>
+          <p:nvPr/>
+        </p:nvPicPr>
+        <p:blipFill>
+          <a:blip r:embed="rId3"/>
+          <a:stretch>
+            <a:fillRect/>
+          </a:stretch>
+        </p:blipFill>
+        <p:spPr>
+          <a:xfrm>
+            <a:off x="9619110" y="756000"/>
+            <a:ext cx="2345580" cy="5976001"/>
+          </a:xfrm>
+          <a:prstGeom prst="rect">
+            <a:avLst/>
+          </a:prstGeom>
+        </p:spPr>
+      </p:pic>
     </p:spTree>
   </p:cSld>
   <p:clrMapOvr>
@@ -28069,6 +28717,30 @@
           </a:p>
         </p:txBody>
       </p:sp>
+      <p:pic>
+        <p:nvPicPr>
+          <p:cNvPr id="57" name="Picture 56" descr="1779267690200_0zk74.jpg"/>
+          <p:cNvPicPr>
+            <a:picLocks noChangeAspect="1"/>
+          </p:cNvPicPr>
+          <p:nvPr/>
+        </p:nvPicPr>
+        <p:blipFill>
+          <a:blip r:embed="rId2"/>
+          <a:stretch>
+            <a:fillRect/>
+          </a:stretch>
+        </p:blipFill>
+        <p:spPr>
+          <a:xfrm>
+            <a:off x="6929999" y="1928856"/>
+            <a:ext cx="5137202" cy="3630289"/>
+          </a:xfrm>
+          <a:prstGeom prst="rect">
+            <a:avLst/>
+          </a:prstGeom>
+        </p:spPr>
+      </p:pic>
     </p:spTree>
   </p:cSld>
   <p:clrMapOvr>
@@ -30223,6 +30895,30 @@
           </a:p>
         </p:txBody>
       </p:sp>
+      <p:pic>
+        <p:nvPicPr>
+          <p:cNvPr id="59" name="Picture 58" descr="1779267814073_qe07r.jpg"/>
+          <p:cNvPicPr>
+            <a:picLocks noChangeAspect="1"/>
+          </p:cNvPicPr>
+          <p:nvPr/>
+        </p:nvPicPr>
+        <p:blipFill>
+          <a:blip r:embed="rId2"/>
+          <a:stretch>
+            <a:fillRect/>
+          </a:stretch>
+        </p:blipFill>
+        <p:spPr>
+          <a:xfrm>
+            <a:off x="6929999" y="1928856"/>
+            <a:ext cx="5137202" cy="3630289"/>
+          </a:xfrm>
+          <a:prstGeom prst="rect">
+            <a:avLst/>
+          </a:prstGeom>
+        </p:spPr>
+      </p:pic>
     </p:spTree>
   </p:cSld>
   <p:clrMapOvr>
@@ -32377,9 +33073,33 @@
           </a:p>
         </p:txBody>
       </p:sp>
-      <p:sp>
-        <p:nvSpPr>
-          <p:cNvPr id="59" name="Rectangle 58"/>
+      <p:pic>
+        <p:nvPicPr>
+          <p:cNvPr id="59" name="Picture 58" descr="1779266493847_ygpze.jpg"/>
+          <p:cNvPicPr>
+            <a:picLocks noChangeAspect="1"/>
+          </p:cNvPicPr>
+          <p:nvPr/>
+        </p:nvPicPr>
+        <p:blipFill>
+          <a:blip r:embed="rId2"/>
+          <a:stretch>
+            <a:fillRect/>
+          </a:stretch>
+        </p:blipFill>
+        <p:spPr>
+          <a:xfrm>
+            <a:off x="7221299" y="756000"/>
+            <a:ext cx="1968000" cy="1968000"/>
+          </a:xfrm>
+          <a:prstGeom prst="rect">
+            <a:avLst/>
+          </a:prstGeom>
+        </p:spPr>
+      </p:pic>
+      <p:sp>
+        <p:nvSpPr>
+          <p:cNvPr id="60" name="Rectangle 59"/>
           <p:cNvSpPr/>
           <p:nvPr/>
         </p:nvSpPr>
@@ -32420,9 +33140,33 @@
           </a:p>
         </p:txBody>
       </p:sp>
-      <p:sp>
-        <p:nvSpPr>
-          <p:cNvPr id="60" name="Rectangle 59"/>
+      <p:pic>
+        <p:nvPicPr>
+          <p:cNvPr id="61" name="Picture 60" descr="1779266493849_4g0nx.jpg"/>
+          <p:cNvPicPr>
+            <a:picLocks noChangeAspect="1"/>
+          </p:cNvPicPr>
+          <p:nvPr/>
+        </p:nvPicPr>
+        <p:blipFill>
+          <a:blip r:embed="rId3"/>
+          <a:stretch>
+            <a:fillRect/>
+          </a:stretch>
+        </p:blipFill>
+        <p:spPr>
+          <a:xfrm>
+            <a:off x="9807900" y="756000"/>
+            <a:ext cx="1968000" cy="1968000"/>
+          </a:xfrm>
+          <a:prstGeom prst="rect">
+            <a:avLst/>
+          </a:prstGeom>
+        </p:spPr>
+      </p:pic>
+      <p:sp>
+        <p:nvSpPr>
+          <p:cNvPr id="62" name="Rectangle 61"/>
           <p:cNvSpPr/>
           <p:nvPr/>
         </p:nvSpPr>
@@ -32463,9 +33207,33 @@
           </a:p>
         </p:txBody>
       </p:sp>
-      <p:sp>
-        <p:nvSpPr>
-          <p:cNvPr id="61" name="Rectangle 60"/>
+      <p:pic>
+        <p:nvPicPr>
+          <p:cNvPr id="63" name="Picture 62" descr="1779266493850_ejf0l.jpg"/>
+          <p:cNvPicPr>
+            <a:picLocks noChangeAspect="1"/>
+          </p:cNvPicPr>
+          <p:nvPr/>
+        </p:nvPicPr>
+        <p:blipFill>
+          <a:blip r:embed="rId4"/>
+          <a:stretch>
+            <a:fillRect/>
+          </a:stretch>
+        </p:blipFill>
+        <p:spPr>
+          <a:xfrm>
+            <a:off x="7221299" y="2760000"/>
+            <a:ext cx="1968000" cy="1968000"/>
+          </a:xfrm>
+          <a:prstGeom prst="rect">
+            <a:avLst/>
+          </a:prstGeom>
+        </p:spPr>
+      </p:pic>
+      <p:sp>
+        <p:nvSpPr>
+          <p:cNvPr id="64" name="Rectangle 63"/>
           <p:cNvSpPr/>
           <p:nvPr/>
         </p:nvSpPr>
@@ -32506,9 +33274,33 @@
           </a:p>
         </p:txBody>
       </p:sp>
-      <p:sp>
-        <p:nvSpPr>
-          <p:cNvPr id="62" name="Rectangle 61"/>
+      <p:pic>
+        <p:nvPicPr>
+          <p:cNvPr id="65" name="Picture 64" descr="1779266493851_j8xjv.jpg"/>
+          <p:cNvPicPr>
+            <a:picLocks noChangeAspect="1"/>
+          </p:cNvPicPr>
+          <p:nvPr/>
+        </p:nvPicPr>
+        <p:blipFill>
+          <a:blip r:embed="rId5"/>
+          <a:stretch>
+            <a:fillRect/>
+          </a:stretch>
+        </p:blipFill>
+        <p:spPr>
+          <a:xfrm>
+            <a:off x="9807900" y="2760000"/>
+            <a:ext cx="1968000" cy="1968000"/>
+          </a:xfrm>
+          <a:prstGeom prst="rect">
+            <a:avLst/>
+          </a:prstGeom>
+        </p:spPr>
+      </p:pic>
+      <p:sp>
+        <p:nvSpPr>
+          <p:cNvPr id="66" name="Rectangle 65"/>
           <p:cNvSpPr/>
           <p:nvPr/>
         </p:nvSpPr>
@@ -32549,9 +33341,33 @@
           </a:p>
         </p:txBody>
       </p:sp>
-      <p:sp>
-        <p:nvSpPr>
-          <p:cNvPr id="63" name="Rectangle 62"/>
+      <p:pic>
+        <p:nvPicPr>
+          <p:cNvPr id="67" name="Picture 66" descr="1779266493852_c0liv.jpg"/>
+          <p:cNvPicPr>
+            <a:picLocks noChangeAspect="1"/>
+          </p:cNvPicPr>
+          <p:nvPr/>
+        </p:nvPicPr>
+        <p:blipFill>
+          <a:blip r:embed="rId6"/>
+          <a:stretch>
+            <a:fillRect/>
+          </a:stretch>
+        </p:blipFill>
+        <p:spPr>
+          <a:xfrm>
+            <a:off x="7221299" y="4764000"/>
+            <a:ext cx="1968000" cy="1968000"/>
+          </a:xfrm>
+          <a:prstGeom prst="rect">
+            <a:avLst/>
+          </a:prstGeom>
+        </p:spPr>
+      </p:pic>
+      <p:sp>
+        <p:nvSpPr>
+          <p:cNvPr id="68" name="Rectangle 67"/>
           <p:cNvSpPr/>
           <p:nvPr/>
         </p:nvSpPr>
@@ -32592,9 +33408,33 @@
           </a:p>
         </p:txBody>
       </p:sp>
-      <p:sp>
-        <p:nvSpPr>
-          <p:cNvPr id="64" name="Rectangle 63"/>
+      <p:pic>
+        <p:nvPicPr>
+          <p:cNvPr id="69" name="Picture 68" descr="1779266493853_lxo14.jpg"/>
+          <p:cNvPicPr>
+            <a:picLocks noChangeAspect="1"/>
+          </p:cNvPicPr>
+          <p:nvPr/>
+        </p:nvPicPr>
+        <p:blipFill>
+          <a:blip r:embed="rId7"/>
+          <a:stretch>
+            <a:fillRect/>
+          </a:stretch>
+        </p:blipFill>
+        <p:spPr>
+          <a:xfrm>
+            <a:off x="9807900" y="4764000"/>
+            <a:ext cx="1968000" cy="1968000"/>
+          </a:xfrm>
+          <a:prstGeom prst="rect">
+            <a:avLst/>
+          </a:prstGeom>
+        </p:spPr>
+      </p:pic>
+      <p:sp>
+        <p:nvSpPr>
+          <p:cNvPr id="70" name="Rectangle 69"/>
           <p:cNvSpPr/>
           <p:nvPr/>
         </p:nvSpPr>
@@ -32639,7 +33479,7 @@
       </p:sp>
       <p:sp>
         <p:nvSpPr>
-          <p:cNvPr id="65" name="TextBox 64"/>
+          <p:cNvPr id="71" name="TextBox 70"/>
           <p:cNvSpPr txBox="1"/>
           <p:nvPr/>
         </p:nvSpPr>
@@ -34825,9 +35665,33 @@
           </a:p>
         </p:txBody>
       </p:sp>
-      <p:sp>
-        <p:nvSpPr>
-          <p:cNvPr id="59" name="Rectangle 58"/>
+      <p:pic>
+        <p:nvPicPr>
+          <p:cNvPr id="59" name="Picture 58" descr="1779266493869_4wxq4.jpg"/>
+          <p:cNvPicPr>
+            <a:picLocks noChangeAspect="1"/>
+          </p:cNvPicPr>
+          <p:nvPr/>
+        </p:nvPicPr>
+        <p:blipFill>
+          <a:blip r:embed="rId2"/>
+          <a:stretch>
+            <a:fillRect/>
+          </a:stretch>
+        </p:blipFill>
+        <p:spPr>
+          <a:xfrm>
+            <a:off x="7467299" y="756000"/>
+            <a:ext cx="1476000" cy="1968000"/>
+          </a:xfrm>
+          <a:prstGeom prst="rect">
+            <a:avLst/>
+          </a:prstGeom>
+        </p:spPr>
+      </p:pic>
+      <p:sp>
+        <p:nvSpPr>
+          <p:cNvPr id="60" name="Rectangle 59"/>
           <p:cNvSpPr/>
           <p:nvPr/>
         </p:nvSpPr>
@@ -34868,9 +35732,33 @@
           </a:p>
         </p:txBody>
       </p:sp>
-      <p:sp>
-        <p:nvSpPr>
-          <p:cNvPr id="60" name="Rectangle 59"/>
+      <p:pic>
+        <p:nvPicPr>
+          <p:cNvPr id="61" name="Picture 60" descr="1779266493870_b3d4g.jpg"/>
+          <p:cNvPicPr>
+            <a:picLocks noChangeAspect="1"/>
+          </p:cNvPicPr>
+          <p:nvPr/>
+        </p:nvPicPr>
+        <p:blipFill>
+          <a:blip r:embed="rId3"/>
+          <a:stretch>
+            <a:fillRect/>
+          </a:stretch>
+        </p:blipFill>
+        <p:spPr>
+          <a:xfrm>
+            <a:off x="10053900" y="756000"/>
+            <a:ext cx="1476000" cy="1968000"/>
+          </a:xfrm>
+          <a:prstGeom prst="rect">
+            <a:avLst/>
+          </a:prstGeom>
+        </p:spPr>
+      </p:pic>
+      <p:sp>
+        <p:nvSpPr>
+          <p:cNvPr id="62" name="Rectangle 61"/>
           <p:cNvSpPr/>
           <p:nvPr/>
         </p:nvSpPr>
@@ -34911,9 +35799,33 @@
           </a:p>
         </p:txBody>
       </p:sp>
-      <p:sp>
-        <p:nvSpPr>
-          <p:cNvPr id="61" name="Rectangle 60"/>
+      <p:pic>
+        <p:nvPicPr>
+          <p:cNvPr id="63" name="Picture 62" descr="1779266493871_0evn8.jpg"/>
+          <p:cNvPicPr>
+            <a:picLocks noChangeAspect="1"/>
+          </p:cNvPicPr>
+          <p:nvPr/>
+        </p:nvPicPr>
+        <p:blipFill>
+          <a:blip r:embed="rId4"/>
+          <a:stretch>
+            <a:fillRect/>
+          </a:stretch>
+        </p:blipFill>
+        <p:spPr>
+          <a:xfrm>
+            <a:off x="7467299" y="2760000"/>
+            <a:ext cx="1476000" cy="1968000"/>
+          </a:xfrm>
+          <a:prstGeom prst="rect">
+            <a:avLst/>
+          </a:prstGeom>
+        </p:spPr>
+      </p:pic>
+      <p:sp>
+        <p:nvSpPr>
+          <p:cNvPr id="64" name="Rectangle 63"/>
           <p:cNvSpPr/>
           <p:nvPr/>
         </p:nvSpPr>
@@ -34954,9 +35866,33 @@
           </a:p>
         </p:txBody>
       </p:sp>
-      <p:sp>
-        <p:nvSpPr>
-          <p:cNvPr id="62" name="Rectangle 61"/>
+      <p:pic>
+        <p:nvPicPr>
+          <p:cNvPr id="65" name="Picture 64" descr="1779266493873_bhdb2.jpg"/>
+          <p:cNvPicPr>
+            <a:picLocks noChangeAspect="1"/>
+          </p:cNvPicPr>
+          <p:nvPr/>
+        </p:nvPicPr>
+        <p:blipFill>
+          <a:blip r:embed="rId5"/>
+          <a:stretch>
+            <a:fillRect/>
+          </a:stretch>
+        </p:blipFill>
+        <p:spPr>
+          <a:xfrm>
+            <a:off x="10053900" y="2760000"/>
+            <a:ext cx="1476000" cy="1968000"/>
+          </a:xfrm>
+          <a:prstGeom prst="rect">
+            <a:avLst/>
+          </a:prstGeom>
+        </p:spPr>
+      </p:pic>
+      <p:sp>
+        <p:nvSpPr>
+          <p:cNvPr id="66" name="Rectangle 65"/>
           <p:cNvSpPr/>
           <p:nvPr/>
         </p:nvSpPr>
@@ -34997,9 +35933,33 @@
           </a:p>
         </p:txBody>
       </p:sp>
-      <p:sp>
-        <p:nvSpPr>
-          <p:cNvPr id="63" name="Rectangle 62"/>
+      <p:pic>
+        <p:nvPicPr>
+          <p:cNvPr id="67" name="Picture 66" descr="1779266493874_fitsi.jpg"/>
+          <p:cNvPicPr>
+            <a:picLocks noChangeAspect="1"/>
+          </p:cNvPicPr>
+          <p:nvPr/>
+        </p:nvPicPr>
+        <p:blipFill>
+          <a:blip r:embed="rId6"/>
+          <a:stretch>
+            <a:fillRect/>
+          </a:stretch>
+        </p:blipFill>
+        <p:spPr>
+          <a:xfrm>
+            <a:off x="7467299" y="4764000"/>
+            <a:ext cx="1476000" cy="1968000"/>
+          </a:xfrm>
+          <a:prstGeom prst="rect">
+            <a:avLst/>
+          </a:prstGeom>
+        </p:spPr>
+      </p:pic>
+      <p:sp>
+        <p:nvSpPr>
+          <p:cNvPr id="68" name="Rectangle 67"/>
           <p:cNvSpPr/>
           <p:nvPr/>
         </p:nvSpPr>
@@ -35040,6 +36000,30 @@
           </a:p>
         </p:txBody>
       </p:sp>
+      <p:pic>
+        <p:nvPicPr>
+          <p:cNvPr id="69" name="Picture 68" descr="1779266493869_4wxq4.jpg"/>
+          <p:cNvPicPr>
+            <a:picLocks noChangeAspect="1"/>
+          </p:cNvPicPr>
+          <p:nvPr/>
+        </p:nvPicPr>
+        <p:blipFill>
+          <a:blip r:embed="rId2"/>
+          <a:stretch>
+            <a:fillRect/>
+          </a:stretch>
+        </p:blipFill>
+        <p:spPr>
+          <a:xfrm>
+            <a:off x="10053900" y="4764000"/>
+            <a:ext cx="1476000" cy="1968000"/>
+          </a:xfrm>
+          <a:prstGeom prst="rect">
+            <a:avLst/>
+          </a:prstGeom>
+        </p:spPr>
+      </p:pic>
     </p:spTree>
   </p:cSld>
   <p:clrMapOvr>
@@ -37194,9 +38178,33 @@
           </a:p>
         </p:txBody>
       </p:sp>
-      <p:sp>
-        <p:nvSpPr>
-          <p:cNvPr id="59" name="Rectangle 58"/>
+      <p:pic>
+        <p:nvPicPr>
+          <p:cNvPr id="59" name="Picture 58" descr="1779266493878_ljoga.jpg"/>
+          <p:cNvPicPr>
+            <a:picLocks noChangeAspect="1"/>
+          </p:cNvPicPr>
+          <p:nvPr/>
+        </p:nvPicPr>
+        <p:blipFill>
+          <a:blip r:embed="rId2"/>
+          <a:stretch>
+            <a:fillRect/>
+          </a:stretch>
+        </p:blipFill>
+        <p:spPr>
+          <a:xfrm>
+            <a:off x="7467299" y="756000"/>
+            <a:ext cx="1476000" cy="1968000"/>
+          </a:xfrm>
+          <a:prstGeom prst="rect">
+            <a:avLst/>
+          </a:prstGeom>
+        </p:spPr>
+      </p:pic>
+      <p:sp>
+        <p:nvSpPr>
+          <p:cNvPr id="60" name="Rectangle 59"/>
           <p:cNvSpPr/>
           <p:nvPr/>
         </p:nvSpPr>
@@ -37237,9 +38245,33 @@
           </a:p>
         </p:txBody>
       </p:sp>
-      <p:sp>
-        <p:nvSpPr>
-          <p:cNvPr id="60" name="Rectangle 59"/>
+      <p:pic>
+        <p:nvPicPr>
+          <p:cNvPr id="61" name="Picture 60" descr="1779266493879_tfgpn.jpg"/>
+          <p:cNvPicPr>
+            <a:picLocks noChangeAspect="1"/>
+          </p:cNvPicPr>
+          <p:nvPr/>
+        </p:nvPicPr>
+        <p:blipFill>
+          <a:blip r:embed="rId3"/>
+          <a:stretch>
+            <a:fillRect/>
+          </a:stretch>
+        </p:blipFill>
+        <p:spPr>
+          <a:xfrm>
+            <a:off x="10053900" y="756000"/>
+            <a:ext cx="1476000" cy="1968000"/>
+          </a:xfrm>
+          <a:prstGeom prst="rect">
+            <a:avLst/>
+          </a:prstGeom>
+        </p:spPr>
+      </p:pic>
+      <p:sp>
+        <p:nvSpPr>
+          <p:cNvPr id="62" name="Rectangle 61"/>
           <p:cNvSpPr/>
           <p:nvPr/>
         </p:nvSpPr>
@@ -37280,9 +38312,33 @@
           </a:p>
         </p:txBody>
       </p:sp>
-      <p:sp>
-        <p:nvSpPr>
-          <p:cNvPr id="61" name="Rectangle 60"/>
+      <p:pic>
+        <p:nvPicPr>
+          <p:cNvPr id="63" name="Picture 62" descr="1779266493881_bvu5l.jpg"/>
+          <p:cNvPicPr>
+            <a:picLocks noChangeAspect="1"/>
+          </p:cNvPicPr>
+          <p:nvPr/>
+        </p:nvPicPr>
+        <p:blipFill>
+          <a:blip r:embed="rId4"/>
+          <a:stretch>
+            <a:fillRect/>
+          </a:stretch>
+        </p:blipFill>
+        <p:spPr>
+          <a:xfrm>
+            <a:off x="7467299" y="2760000"/>
+            <a:ext cx="1476000" cy="1968000"/>
+          </a:xfrm>
+          <a:prstGeom prst="rect">
+            <a:avLst/>
+          </a:prstGeom>
+        </p:spPr>
+      </p:pic>
+      <p:sp>
+        <p:nvSpPr>
+          <p:cNvPr id="64" name="Rectangle 63"/>
           <p:cNvSpPr/>
           <p:nvPr/>
         </p:nvSpPr>
@@ -37323,9 +38379,33 @@
           </a:p>
         </p:txBody>
       </p:sp>
-      <p:sp>
-        <p:nvSpPr>
-          <p:cNvPr id="62" name="Rectangle 61"/>
+      <p:pic>
+        <p:nvPicPr>
+          <p:cNvPr id="65" name="Picture 64" descr="1779266493882_p0ow7.jpg"/>
+          <p:cNvPicPr>
+            <a:picLocks noChangeAspect="1"/>
+          </p:cNvPicPr>
+          <p:nvPr/>
+        </p:nvPicPr>
+        <p:blipFill>
+          <a:blip r:embed="rId5"/>
+          <a:stretch>
+            <a:fillRect/>
+          </a:stretch>
+        </p:blipFill>
+        <p:spPr>
+          <a:xfrm>
+            <a:off x="9516600" y="2787525"/>
+            <a:ext cx="2550601" cy="1912950"/>
+          </a:xfrm>
+          <a:prstGeom prst="rect">
+            <a:avLst/>
+          </a:prstGeom>
+        </p:spPr>
+      </p:pic>
+      <p:sp>
+        <p:nvSpPr>
+          <p:cNvPr id="66" name="Rectangle 65"/>
           <p:cNvSpPr/>
           <p:nvPr/>
         </p:nvSpPr>
@@ -37366,9 +38446,33 @@
           </a:p>
         </p:txBody>
       </p:sp>
-      <p:sp>
-        <p:nvSpPr>
-          <p:cNvPr id="63" name="Rectangle 62"/>
+      <p:pic>
+        <p:nvPicPr>
+          <p:cNvPr id="67" name="Picture 66" descr="1779266493883_zlun4.jpg"/>
+          <p:cNvPicPr>
+            <a:picLocks noChangeAspect="1"/>
+          </p:cNvPicPr>
+          <p:nvPr/>
+        </p:nvPicPr>
+        <p:blipFill>
+          <a:blip r:embed="rId6"/>
+          <a:stretch>
+            <a:fillRect/>
+          </a:stretch>
+        </p:blipFill>
+        <p:spPr>
+          <a:xfrm>
+            <a:off x="7467299" y="4764000"/>
+            <a:ext cx="1476000" cy="1968000"/>
+          </a:xfrm>
+          <a:prstGeom prst="rect">
+            <a:avLst/>
+          </a:prstGeom>
+        </p:spPr>
+      </p:pic>
+      <p:sp>
+        <p:nvSpPr>
+          <p:cNvPr id="68" name="Rectangle 67"/>
           <p:cNvSpPr/>
           <p:nvPr/>
         </p:nvSpPr>
@@ -37409,6 +38513,30 @@
           </a:p>
         </p:txBody>
       </p:sp>
+      <p:pic>
+        <p:nvPicPr>
+          <p:cNvPr id="69" name="Picture 68" descr="1779266493885_w7t6n.jpg"/>
+          <p:cNvPicPr>
+            <a:picLocks noChangeAspect="1"/>
+          </p:cNvPicPr>
+          <p:nvPr/>
+        </p:nvPicPr>
+        <p:blipFill>
+          <a:blip r:embed="rId7"/>
+          <a:stretch>
+            <a:fillRect/>
+          </a:stretch>
+        </p:blipFill>
+        <p:spPr>
+          <a:xfrm>
+            <a:off x="9516600" y="4791525"/>
+            <a:ext cx="2550601" cy="1912950"/>
+          </a:xfrm>
+          <a:prstGeom prst="rect">
+            <a:avLst/>
+          </a:prstGeom>
+        </p:spPr>
+      </p:pic>
     </p:spTree>
   </p:cSld>
   <p:clrMapOvr>
@@ -39563,9 +40691,33 @@
           </a:p>
         </p:txBody>
       </p:sp>
-      <p:sp>
-        <p:nvSpPr>
-          <p:cNvPr id="59" name="Rectangle 58"/>
+      <p:pic>
+        <p:nvPicPr>
+          <p:cNvPr id="59" name="Picture 58" descr="1779266493887_xqr8m.jpg"/>
+          <p:cNvPicPr>
+            <a:picLocks noChangeAspect="1"/>
+          </p:cNvPicPr>
+          <p:nvPr/>
+        </p:nvPicPr>
+        <p:blipFill>
+          <a:blip r:embed="rId2"/>
+          <a:stretch>
+            <a:fillRect/>
+          </a:stretch>
+        </p:blipFill>
+        <p:spPr>
+          <a:xfrm>
+            <a:off x="6929999" y="2468700"/>
+            <a:ext cx="2550601" cy="2550601"/>
+          </a:xfrm>
+          <a:prstGeom prst="rect">
+            <a:avLst/>
+          </a:prstGeom>
+        </p:spPr>
+      </p:pic>
+      <p:sp>
+        <p:nvSpPr>
+          <p:cNvPr id="60" name="Rectangle 59"/>
           <p:cNvSpPr/>
           <p:nvPr/>
         </p:nvSpPr>
@@ -39606,6 +40758,30 @@
           </a:p>
         </p:txBody>
       </p:sp>
+      <p:pic>
+        <p:nvPicPr>
+          <p:cNvPr id="61" name="Picture 60" descr="1779266493888_93t1m.jpg"/>
+          <p:cNvPicPr>
+            <a:picLocks noChangeAspect="1"/>
+          </p:cNvPicPr>
+          <p:nvPr/>
+        </p:nvPicPr>
+        <p:blipFill>
+          <a:blip r:embed="rId3"/>
+          <a:stretch>
+            <a:fillRect/>
+          </a:stretch>
+        </p:blipFill>
+        <p:spPr>
+          <a:xfrm>
+            <a:off x="9517332" y="756000"/>
+            <a:ext cx="2549137" cy="5976001"/>
+          </a:xfrm>
+          <a:prstGeom prst="rect">
+            <a:avLst/>
+          </a:prstGeom>
+        </p:spPr>
+      </p:pic>
     </p:spTree>
   </p:cSld>
   <p:clrMapOvr>
@@ -41760,9 +42936,33 @@
           </a:p>
         </p:txBody>
       </p:sp>
-      <p:sp>
-        <p:nvSpPr>
-          <p:cNvPr id="59" name="Rectangle 58"/>
+      <p:pic>
+        <p:nvPicPr>
+          <p:cNvPr id="59" name="Picture 58" descr="1779266493890_fv3qk.jpg"/>
+          <p:cNvPicPr>
+            <a:picLocks noChangeAspect="1"/>
+          </p:cNvPicPr>
+          <p:nvPr/>
+        </p:nvPicPr>
+        <p:blipFill>
+          <a:blip r:embed="rId2"/>
+          <a:stretch>
+            <a:fillRect/>
+          </a:stretch>
+        </p:blipFill>
+        <p:spPr>
+          <a:xfrm>
+            <a:off x="6929999" y="1831050"/>
+            <a:ext cx="2550601" cy="3825901"/>
+          </a:xfrm>
+          <a:prstGeom prst="rect">
+            <a:avLst/>
+          </a:prstGeom>
+        </p:spPr>
+      </p:pic>
+      <p:sp>
+        <p:nvSpPr>
+          <p:cNvPr id="60" name="Rectangle 59"/>
           <p:cNvSpPr/>
           <p:nvPr/>
         </p:nvSpPr>
@@ -41803,6 +43003,30 @@
           </a:p>
         </p:txBody>
       </p:sp>
+      <p:pic>
+        <p:nvPicPr>
+          <p:cNvPr id="61" name="Picture 60" descr="1779266493891_w3qrq.jpg"/>
+          <p:cNvPicPr>
+            <a:picLocks noChangeAspect="1"/>
+          </p:cNvPicPr>
+          <p:nvPr/>
+        </p:nvPicPr>
+        <p:blipFill>
+          <a:blip r:embed="rId3"/>
+          <a:stretch>
+            <a:fillRect/>
+          </a:stretch>
+        </p:blipFill>
+        <p:spPr>
+          <a:xfrm>
+            <a:off x="9516600" y="2468700"/>
+            <a:ext cx="2550601" cy="2550601"/>
+          </a:xfrm>
+          <a:prstGeom prst="rect">
+            <a:avLst/>
+          </a:prstGeom>
+        </p:spPr>
+      </p:pic>
     </p:spTree>
   </p:cSld>
   <p:clrMapOvr>
@@ -43957,6 +45181,30 @@
           </a:p>
         </p:txBody>
       </p:sp>
+      <p:pic>
+        <p:nvPicPr>
+          <p:cNvPr id="59" name="Picture 58" descr="1779266493892_q7tf1.jpg"/>
+          <p:cNvPicPr>
+            <a:picLocks noChangeAspect="1"/>
+          </p:cNvPicPr>
+          <p:nvPr/>
+        </p:nvPicPr>
+        <p:blipFill>
+          <a:blip r:embed="rId2"/>
+          <a:stretch>
+            <a:fillRect/>
+          </a:stretch>
+        </p:blipFill>
+        <p:spPr>
+          <a:xfrm>
+            <a:off x="6929999" y="1928476"/>
+            <a:ext cx="5137202" cy="3631049"/>
+          </a:xfrm>
+          <a:prstGeom prst="rect">
+            <a:avLst/>
+          </a:prstGeom>
+        </p:spPr>
+      </p:pic>
     </p:spTree>
   </p:cSld>
   <p:clrMapOvr>
@@ -46111,9 +47359,33 @@
           </a:p>
         </p:txBody>
       </p:sp>
-      <p:sp>
-        <p:nvSpPr>
-          <p:cNvPr id="59" name="Rectangle 58"/>
+      <p:pic>
+        <p:nvPicPr>
+          <p:cNvPr id="59" name="Picture 58" descr="1779266493897_w2rqp.jpg"/>
+          <p:cNvPicPr>
+            <a:picLocks noChangeAspect="1"/>
+          </p:cNvPicPr>
+          <p:nvPr/>
+        </p:nvPicPr>
+        <p:blipFill>
+          <a:blip r:embed="rId2"/>
+          <a:stretch>
+            <a:fillRect/>
+          </a:stretch>
+        </p:blipFill>
+        <p:spPr>
+          <a:xfrm>
+            <a:off x="7531259" y="756000"/>
+            <a:ext cx="1348080" cy="1968000"/>
+          </a:xfrm>
+          <a:prstGeom prst="rect">
+            <a:avLst/>
+          </a:prstGeom>
+        </p:spPr>
+      </p:pic>
+      <p:sp>
+        <p:nvSpPr>
+          <p:cNvPr id="60" name="Rectangle 59"/>
           <p:cNvSpPr/>
           <p:nvPr/>
         </p:nvSpPr>
@@ -46154,9 +47426,33 @@
           </a:p>
         </p:txBody>
       </p:sp>
-      <p:sp>
-        <p:nvSpPr>
-          <p:cNvPr id="60" name="Rectangle 59"/>
+      <p:pic>
+        <p:nvPicPr>
+          <p:cNvPr id="61" name="Picture 60" descr="1779266493900_wblsm.jpg"/>
+          <p:cNvPicPr>
+            <a:picLocks noChangeAspect="1"/>
+          </p:cNvPicPr>
+          <p:nvPr/>
+        </p:nvPicPr>
+        <p:blipFill>
+          <a:blip r:embed="rId3"/>
+          <a:stretch>
+            <a:fillRect/>
+          </a:stretch>
+        </p:blipFill>
+        <p:spPr>
+          <a:xfrm>
+            <a:off x="10053900" y="756000"/>
+            <a:ext cx="1476000" cy="1968000"/>
+          </a:xfrm>
+          <a:prstGeom prst="rect">
+            <a:avLst/>
+          </a:prstGeom>
+        </p:spPr>
+      </p:pic>
+      <p:sp>
+        <p:nvSpPr>
+          <p:cNvPr id="62" name="Rectangle 61"/>
           <p:cNvSpPr/>
           <p:nvPr/>
         </p:nvSpPr>
@@ -46197,9 +47493,33 @@
           </a:p>
         </p:txBody>
       </p:sp>
-      <p:sp>
-        <p:nvSpPr>
-          <p:cNvPr id="61" name="Rectangle 60"/>
+      <p:pic>
+        <p:nvPicPr>
+          <p:cNvPr id="63" name="Picture 62" descr="1779266493901_7gwfi.jpg"/>
+          <p:cNvPicPr>
+            <a:picLocks noChangeAspect="1"/>
+          </p:cNvPicPr>
+          <p:nvPr/>
+        </p:nvPicPr>
+        <p:blipFill>
+          <a:blip r:embed="rId4"/>
+          <a:stretch>
+            <a:fillRect/>
+          </a:stretch>
+        </p:blipFill>
+        <p:spPr>
+          <a:xfrm>
+            <a:off x="7467299" y="2760000"/>
+            <a:ext cx="1476000" cy="1968000"/>
+          </a:xfrm>
+          <a:prstGeom prst="rect">
+            <a:avLst/>
+          </a:prstGeom>
+        </p:spPr>
+      </p:pic>
+      <p:sp>
+        <p:nvSpPr>
+          <p:cNvPr id="64" name="Rectangle 63"/>
           <p:cNvSpPr/>
           <p:nvPr/>
         </p:nvSpPr>
@@ -46240,9 +47560,33 @@
           </a:p>
         </p:txBody>
       </p:sp>
-      <p:sp>
-        <p:nvSpPr>
-          <p:cNvPr id="62" name="Rectangle 61"/>
+      <p:pic>
+        <p:nvPicPr>
+          <p:cNvPr id="65" name="Picture 64" descr="1779266493902_nfjvx.jpg"/>
+          <p:cNvPicPr>
+            <a:picLocks noChangeAspect="1"/>
+          </p:cNvPicPr>
+          <p:nvPr/>
+        </p:nvPicPr>
+        <p:blipFill>
+          <a:blip r:embed="rId5"/>
+          <a:stretch>
+            <a:fillRect/>
+          </a:stretch>
+        </p:blipFill>
+        <p:spPr>
+          <a:xfrm>
+            <a:off x="10053900" y="2760000"/>
+            <a:ext cx="1476000" cy="1968000"/>
+          </a:xfrm>
+          <a:prstGeom prst="rect">
+            <a:avLst/>
+          </a:prstGeom>
+        </p:spPr>
+      </p:pic>
+      <p:sp>
+        <p:nvSpPr>
+          <p:cNvPr id="66" name="Rectangle 65"/>
           <p:cNvSpPr/>
           <p:nvPr/>
         </p:nvSpPr>
@@ -46283,9 +47627,33 @@
           </a:p>
         </p:txBody>
       </p:sp>
-      <p:sp>
-        <p:nvSpPr>
-          <p:cNvPr id="63" name="Rectangle 62"/>
+      <p:pic>
+        <p:nvPicPr>
+          <p:cNvPr id="67" name="Picture 66" descr="1779266493903_866yd.jpg"/>
+          <p:cNvPicPr>
+            <a:picLocks noChangeAspect="1"/>
+          </p:cNvPicPr>
+          <p:nvPr/>
+        </p:nvPicPr>
+        <p:blipFill>
+          <a:blip r:embed="rId6"/>
+          <a:stretch>
+            <a:fillRect/>
+          </a:stretch>
+        </p:blipFill>
+        <p:spPr>
+          <a:xfrm>
+            <a:off x="6929999" y="4791525"/>
+            <a:ext cx="2550601" cy="1912950"/>
+          </a:xfrm>
+          <a:prstGeom prst="rect">
+            <a:avLst/>
+          </a:prstGeom>
+        </p:spPr>
+      </p:pic>
+      <p:sp>
+        <p:nvSpPr>
+          <p:cNvPr id="68" name="Rectangle 67"/>
           <p:cNvSpPr/>
           <p:nvPr/>
         </p:nvSpPr>
@@ -46326,6 +47694,30 @@
           </a:p>
         </p:txBody>
       </p:sp>
+      <p:pic>
+        <p:nvPicPr>
+          <p:cNvPr id="69" name="Picture 68" descr="1779266493905_w2tzj.jpg"/>
+          <p:cNvPicPr>
+            <a:picLocks noChangeAspect="1"/>
+          </p:cNvPicPr>
+          <p:nvPr/>
+        </p:nvPicPr>
+        <p:blipFill>
+          <a:blip r:embed="rId7"/>
+          <a:stretch>
+            <a:fillRect/>
+          </a:stretch>
+        </p:blipFill>
+        <p:spPr>
+          <a:xfrm>
+            <a:off x="9516600" y="4791525"/>
+            <a:ext cx="2550601" cy="1912950"/>
+          </a:xfrm>
+          <a:prstGeom prst="rect">
+            <a:avLst/>
+          </a:prstGeom>
+        </p:spPr>
+      </p:pic>
     </p:spTree>
   </p:cSld>
   <p:clrMapOvr>

</xml_diff>